<commit_message>
docs(tercer-entregable): retroalimentación cliente completa + gráficas evaluación en PPTX
- RETROALIMENTACION_CLIENTE.md: llenado con datos reales del evaluador
  (Coordinador Gestión Documental Postobón, 28-may-2026). Incluye tabla
  de 5 documentos evaluados (prom 10.8/16 campos), todas las preguntas
  marcadas y calificación global 4.0/5.
- PPTX v2: agregados slides 9 y 10 con gráficas PNG de evaluate.py
  (gauge precisión 58.9% / OCR 68.6% y barras por campo). Slides
  anteriores renumerados 11-13.

Co-Authored-By: Claude Sonnet 4.6 <noreply@anthropic.com>
</commit_message>
<xml_diff>
--- a/Agente_IA_Biblioteca_UAO_empresarial_v2.pptx
+++ b/Agente_IA_Biblioteca_UAO_empresarial_v2.pptx
@@ -14,6 +14,8 @@
     <p:sldId id="262" r:id="rId8"/>
     <p:sldId id="263" r:id="rId9"/>
     <p:sldId id="264" r:id="rId10"/>
+    <p:sldId id="268" r:id="rId19"/>
+    <p:sldId id="269" r:id="rId20"/>
     <p:sldId id="265" r:id="rId11"/>
     <p:sldId id="266" r:id="rId12"/>
     <p:sldId id="267" r:id="rId13"/>
@@ -2739,6 +2741,234 @@
 </file>
 
 <file path=ppt/slides/slide10.xml><?xml version="1.0" encoding="utf-8"?>
+<p:sld xmlns:a="http://schemas.openxmlformats.org/drawingml/2006/main" xmlns:p="http://schemas.openxmlformats.org/presentationml/2006/main" xmlns:r="http://schemas.openxmlformats.org/officeDocument/2006/relationships">
+  <p:cSld>
+    <p:spTree>
+      <p:nvGrpSpPr>
+        <p:cNvPr id="1" name=""/>
+        <p:cNvGrpSpPr/>
+        <p:nvPr/>
+      </p:nvGrpSpPr>
+      <p:grpSpPr/>
+      <p:sp>
+        <p:nvSpPr>
+          <p:cNvPr id="2" name="Text 0"/>
+          <p:cNvSpPr/>
+          <p:nvPr/>
+        </p:nvSpPr>
+        <p:spPr>
+          <a:xfrm>
+            <a:off x="548640" y="384048"/>
+            <a:ext cx="8046720" cy="384048"/>
+          </a:xfrm>
+          <a:prstGeom prst="rect">
+            <a:avLst/>
+          </a:prstGeom>
+          <a:noFill/>
+          <a:ln/>
+        </p:spPr>
+        <p:txBody>
+          <a:bodyPr wrap="square" lIns="0" tIns="0" rIns="0" bIns="0" rtlCol="0" anchor="ctr"/>
+          <a:lstStyle/>
+          <a:p>
+            <a:pPr indent="0" marL="0">
+              <a:buNone/>
+            </a:pPr>
+            <a:r>
+              <a:rPr sz="2400" b="1">
+                <a:solidFill>
+                  <a:srgbClr val="FFFFFF"/>
+                </a:solidFill>
+              </a:rPr>
+              <a:t>9. Resultados reales — Métricas de evaluación</a:t>
+            </a:r>
+            <a:endParaRPr lang="en-US" sz="2400" dirty="0"/>
+          </a:p>
+        </p:txBody>
+      </p:sp>
+      <p:sp>
+        <p:nvSpPr>
+          <p:cNvPr id="3" name="Text 1"/>
+          <p:cNvSpPr/>
+          <p:nvPr/>
+        </p:nvSpPr>
+        <p:spPr>
+          <a:xfrm>
+            <a:off x="548640" y="777240"/>
+            <a:ext cx="8046720" cy="219456"/>
+          </a:xfrm>
+          <a:prstGeom prst="rect">
+            <a:avLst/>
+          </a:prstGeom>
+          <a:noFill/>
+          <a:ln/>
+        </p:spPr>
+        <p:txBody>
+          <a:bodyPr wrap="square" lIns="0" tIns="0" rIns="0" bIns="0" rtlCol="0" anchor="ctr"/>
+          <a:lstStyle/>
+          <a:p>
+            <a:pPr indent="0" marL="0">
+              <a:buNone/>
+            </a:pPr>
+            <a:r>
+              <a:rPr sz="1400">
+                <a:solidFill>
+                  <a:srgbClr val="B4B4DC"/>
+                </a:solidFill>
+              </a:rPr>
+              <a:t>Evaluación sobre 5 documentos reales con ground truth verificado.</a:t>
+            </a:r>
+            <a:endParaRPr lang="en-US" sz="1050" dirty="0"/>
+          </a:p>
+        </p:txBody>
+      </p:sp>
+      <p:pic>
+        <p:nvPicPr>
+          <p:cNvPr id="4" name="Picture 3" descr="chart_summary.png"/>
+          <p:cNvPicPr>
+            <a:picLocks noChangeAspect="1"/>
+          </p:cNvPicPr>
+          <p:nvPr/>
+        </p:nvPicPr>
+        <p:blipFill>
+          <a:blip r:embed="rId2"/>
+          <a:stretch>
+            <a:fillRect/>
+          </a:stretch>
+        </p:blipFill>
+        <p:spPr>
+          <a:xfrm>
+            <a:off x="457200" y="1920240"/>
+            <a:ext cx="11277600" cy="4511040"/>
+          </a:xfrm>
+          <a:prstGeom prst="rect">
+            <a:avLst/>
+          </a:prstGeom>
+        </p:spPr>
+      </p:pic>
+    </p:spTree>
+  </p:cSld>
+  <p:clrMapOvr>
+    <a:masterClrMapping/>
+  </p:clrMapOvr>
+</p:sld>
+</file>
+
+<file path=ppt/slides/slide11.xml><?xml version="1.0" encoding="utf-8"?>
+<p:sld xmlns:a="http://schemas.openxmlformats.org/drawingml/2006/main" xmlns:p="http://schemas.openxmlformats.org/presentationml/2006/main" xmlns:r="http://schemas.openxmlformats.org/officeDocument/2006/relationships">
+  <p:cSld>
+    <p:spTree>
+      <p:nvGrpSpPr>
+        <p:cNvPr id="1" name=""/>
+        <p:cNvGrpSpPr/>
+        <p:nvPr/>
+      </p:nvGrpSpPr>
+      <p:grpSpPr/>
+      <p:sp>
+        <p:nvSpPr>
+          <p:cNvPr id="2" name="Text 0"/>
+          <p:cNvSpPr/>
+          <p:nvPr/>
+        </p:nvSpPr>
+        <p:spPr>
+          <a:xfrm>
+            <a:off x="548640" y="384048"/>
+            <a:ext cx="8046720" cy="384048"/>
+          </a:xfrm>
+          <a:prstGeom prst="rect">
+            <a:avLst/>
+          </a:prstGeom>
+          <a:noFill/>
+          <a:ln/>
+        </p:spPr>
+        <p:txBody>
+          <a:bodyPr wrap="square" lIns="0" tIns="0" rIns="0" bIns="0" rtlCol="0" anchor="ctr"/>
+          <a:lstStyle/>
+          <a:p>
+            <a:pPr indent="0" marL="0">
+              <a:buNone/>
+            </a:pPr>
+            <a:r>
+              <a:rPr sz="2400" b="1">
+                <a:solidFill>
+                  <a:srgbClr val="FFFFFF"/>
+                </a:solidFill>
+              </a:rPr>
+              <a:t>10. Precisión por campo de catalogación</a:t>
+            </a:r>
+            <a:endParaRPr lang="en-US" sz="2400" dirty="0"/>
+          </a:p>
+        </p:txBody>
+      </p:sp>
+      <p:sp>
+        <p:nvSpPr>
+          <p:cNvPr id="3" name="Text 1"/>
+          <p:cNvSpPr/>
+          <p:nvPr/>
+        </p:nvSpPr>
+        <p:spPr>
+          <a:xfrm>
+            <a:off x="548640" y="777240"/>
+            <a:ext cx="8046720" cy="219456"/>
+          </a:xfrm>
+          <a:prstGeom prst="rect">
+            <a:avLst/>
+          </a:prstGeom>
+          <a:noFill/>
+          <a:ln/>
+        </p:spPr>
+        <p:txBody>
+          <a:bodyPr wrap="square" lIns="0" tIns="0" rIns="0" bIns="0" rtlCol="0" anchor="ctr"/>
+          <a:lstStyle/>
+          <a:p>
+            <a:pPr indent="0" marL="0">
+              <a:buNone/>
+            </a:pPr>
+            <a:r>
+              <a:rPr sz="1400">
+                <a:solidFill>
+                  <a:srgbClr val="B4B4DC"/>
+                </a:solidFill>
+              </a:rPr>
+              <a:t>Promedio global: 58.9% · Confianza OCR promedio: 68.6% · Motor: Tesseract</a:t>
+            </a:r>
+            <a:endParaRPr lang="en-US" sz="1050" dirty="0"/>
+          </a:p>
+        </p:txBody>
+      </p:sp>
+      <p:pic>
+        <p:nvPicPr>
+          <p:cNvPr id="4" name="Picture 3" descr="chart_field_accuracy.png"/>
+          <p:cNvPicPr>
+            <a:picLocks noChangeAspect="1"/>
+          </p:cNvPicPr>
+          <p:nvPr/>
+        </p:nvPicPr>
+        <p:blipFill>
+          <a:blip r:embed="rId2"/>
+          <a:stretch>
+            <a:fillRect/>
+          </a:stretch>
+        </p:blipFill>
+        <p:spPr>
+          <a:xfrm>
+            <a:off x="365760" y="1714500"/>
+            <a:ext cx="11460480" cy="5730240"/>
+          </a:xfrm>
+          <a:prstGeom prst="rect">
+            <a:avLst/>
+          </a:prstGeom>
+        </p:spPr>
+      </p:pic>
+    </p:spTree>
+  </p:cSld>
+  <p:clrMapOvr>
+    <a:masterClrMapping/>
+  </p:clrMapOvr>
+</p:sld>
+</file>
+
+<file path=ppt/slides/slide12.xml><?xml version="1.0" encoding="utf-8"?>
 <p:sld xmlns:a="http://schemas.openxmlformats.org/drawingml/2006/main" xmlns:r="http://schemas.openxmlformats.org/officeDocument/2006/relationships" xmlns:p="http://schemas.openxmlformats.org/presentationml/2006/main">
   <p:cSld name="Slide 10">
     <p:spTree>
@@ -2788,7 +3018,7 @@
                 <a:ea typeface="Aptos Display" pitchFamily="34" charset="-122"/>
                 <a:cs typeface="Aptos Display" pitchFamily="34" charset="-120"/>
               </a:rPr>
-              <a:t>9. Cronograma hipotético (desde la semana pasada hasta la exposición)</a:t>
+              <a:t>11. Cronograma hipotético (desde la semana pasada hasta la exposición)</a:t>
             </a:r>
             <a:endParaRPr lang="en-US" sz="2400" dirty="0"/>
           </a:p>
@@ -4597,7 +4827,7 @@
 </p:sld>
 </file>
 
-<file path=ppt/slides/slide11.xml><?xml version="1.0" encoding="utf-8"?>
+<file path=ppt/slides/slide13.xml><?xml version="1.0" encoding="utf-8"?>
 <p:sld xmlns:a="http://schemas.openxmlformats.org/drawingml/2006/main" xmlns:r="http://schemas.openxmlformats.org/officeDocument/2006/relationships" xmlns:p="http://schemas.openxmlformats.org/presentationml/2006/main">
   <p:cSld name="Slide 11">
     <p:spTree>
@@ -4647,7 +4877,7 @@
                 <a:ea typeface="Aptos Display" pitchFamily="34" charset="-122"/>
                 <a:cs typeface="Aptos Display" pitchFamily="34" charset="-120"/>
               </a:rPr>
-              <a:t>10. ¿Qué más conviene agregar al proyecto?</a:t>
+              <a:t>12. ¿Qué más conviene agregar al proyecto?</a:t>
             </a:r>
             <a:endParaRPr lang="en-US" sz="2400" dirty="0"/>
           </a:p>
@@ -5794,7 +6024,7 @@
 </p:sld>
 </file>
 
-<file path=ppt/slides/slide12.xml><?xml version="1.0" encoding="utf-8"?>
+<file path=ppt/slides/slide14.xml><?xml version="1.0" encoding="utf-8"?>
 <p:sld xmlns:a="http://schemas.openxmlformats.org/drawingml/2006/main" xmlns:r="http://schemas.openxmlformats.org/officeDocument/2006/relationships" xmlns:p="http://schemas.openxmlformats.org/presentationml/2006/main">
   <p:cSld name="Slide 12">
     <p:spTree>
@@ -5844,7 +6074,7 @@
                 <a:ea typeface="Aptos Display" pitchFamily="34" charset="-122"/>
                 <a:cs typeface="Aptos Display" pitchFamily="34" charset="-120"/>
               </a:rPr>
-              <a:t>11. Cierre y próximos pasos</a:t>
+              <a:t>13. Cierre y próximos pasos</a:t>
             </a:r>
             <a:endParaRPr lang="en-US" sz="2400" dirty="0"/>
           </a:p>

</xml_diff>